<commit_message>
Pitch PPTX: fairness 36.3% -> 6.3% to match the shipped deck
Co-Authored-By: Claude Opus 4.8 (1M context) <noreply@anthropic.com>
</commit_message>
<xml_diff>
--- a/VoxShield_Pitch.pptx
+++ b/VoxShield_Pitch.pptx
@@ -13915,7 +13915,7 @@
                 </a:solidFill>
                 <a:latin typeface="Consolas"/>
               </a:rPr>
-              <a:t>36.3→11.7%</a:t>
+              <a:t>36.3→6.3%</a:t>
             </a:r>
           </a:p>
         </p:txBody>
@@ -14005,7 +14005,7 @@
                 </a:solidFill>
                 <a:latin typeface="Arial"/>
               </a:rPr>
-              <a:t>genuine Indic speech, after Indic-aware retraining</a:t>
+              <a:t>genuine Indic speech, Indic-aware + channel-aware</a:t>
             </a:r>
           </a:p>
         </p:txBody>
@@ -14712,7 +14712,7 @@
                 </a:solidFill>
                 <a:latin typeface="Consolas"/>
               </a:rPr>
-              <a:t>11.7%</a:t>
+              <a:t>6.3%</a:t>
             </a:r>
           </a:p>
         </p:txBody>

</xml_diff>